<commit_message>
Refocus Scenario 2 basket on Asian AI hardware
Replace the platform and conglomerate names (Sony, Hitachi, SoftBank,
Keyence, Tencent, Alibaba, Xiaomi) with AI-hardware suppliers (Disco,
Shin-Etsu, ASE, Ibiden, Hon Hai, Quanta, Delta). Raise basket vol
regimes to 27%/50% and raw-basket implied vol to 33% for the more
concentrated semiconductor basket, re-run pricing, and update the deck,
Excel model, backtest tickers and strategy write-up.

Co-Authored-By: Claude Opus 5.5 <noreply@anthropic.com>
Claude-Session: https://claude.ai/code/session_01JAuaaaJzDmbMdV7YcMwaXR
</commit_message>
<xml_diff>
--- a/deck/Asia-Digital-Bridge-Note.pptx
+++ b/deck/Asia-Digital-Bridge-Note.pptx
@@ -893,22 +893,22 @@
                   <c:v>100</c:v>
                 </c:pt>
                 <c:pt idx="3">
-                  <c:v>116.39343270583038</c:v>
+                  <c:v>116.3317621728325</c:v>
                 </c:pt>
                 <c:pt idx="4">
-                  <c:v>132.78686541166076</c:v>
+                  <c:v>132.663524345665</c:v>
                 </c:pt>
                 <c:pt idx="5">
-                  <c:v>149.18029811749113</c:v>
+                  <c:v>148.9952865184975</c:v>
                 </c:pt>
                 <c:pt idx="6">
-                  <c:v>181.9671635291519</c:v>
+                  <c:v>181.6588108641625</c:v>
                 </c:pt>
                 <c:pt idx="7">
-                  <c:v>222.95074529372783</c:v>
+                  <c:v>222.4882162962437</c:v>
                 </c:pt>
                 <c:pt idx="8">
-                  <c:v>263.9343270583038</c:v>
+                  <c:v>263.317621728325</c:v>
                 </c:pt>
               </c:numCache>
             </c:numRef>
@@ -1426,19 +1426,19 @@
                 <c:formatCode>General</c:formatCode>
                 <c:ptCount val="5"/>
                 <c:pt idx="0">
-                  <c:v>353</c:v>
+                  <c:v>351</c:v>
                 </c:pt>
                 <c:pt idx="1">
-                  <c:v>215</c:v>
+                  <c:v>214</c:v>
                 </c:pt>
                 <c:pt idx="2">
-                  <c:v>161</c:v>
+                  <c:v>160</c:v>
                 </c:pt>
                 <c:pt idx="3">
-                  <c:v>124</c:v>
+                  <c:v>123</c:v>
                 </c:pt>
                 <c:pt idx="4">
-                  <c:v>95</c:v>
+                  <c:v>89</c:v>
                 </c:pt>
               </c:numCache>
             </c:numRef>
@@ -1762,19 +1762,19 @@
                 <c:formatCode>General</c:formatCode>
                 <c:ptCount val="5"/>
                 <c:pt idx="0">
-                  <c:v>35</c:v>
+                  <c:v>40</c:v>
                 </c:pt>
                 <c:pt idx="1">
-                  <c:v>18</c:v>
+                  <c:v>20</c:v>
                 </c:pt>
                 <c:pt idx="2">
-                  <c:v>12</c:v>
+                  <c:v>14</c:v>
                 </c:pt>
                 <c:pt idx="3">
-                  <c:v>7</c:v>
+                  <c:v>9</c:v>
                 </c:pt>
                 <c:pt idx="4">
-                  <c:v>27</c:v>
+                  <c:v>34</c:v>
                 </c:pt>
               </c:numCache>
             </c:numRef>
@@ -3024,7 +3024,7 @@
           <a:p>
             <a:r>
               <a:rPr lang="en-US" dirty="0"/>
-              <a:t>Pull supporting data from Bloomberg: TSMC share of leading-edge foundry, HBM share for SK Hynix/Samsung, TOPIX ROE trend, AI capex forecasts. Keep claims qualitative until sourced.</a:t>
+              <a:t>Pull supporting data from Bloomberg: TSMC share of leading-edge foundry and CoWoS capacity, HBM share for SK Hynix/Samsung, AI-server share for Hon Hai/Quanta, hyperscaler capex forecasts. Keep claims qualitative until sourced.</a:t>
             </a:r>
             <a:endParaRPr lang="en-US" dirty="0"/>
           </a:p>
@@ -3288,7 +3288,7 @@
           <a:p>
             <a:r>
               <a:rPr lang="en-US" dirty="0"/>
-              <a:t>Because the index volatility is fixed by construction, Natixis can hedge with delta only and price the option off a known vol. That is what makes 164% participation possible on a 7Y Asian basket.</a:t>
+              <a:t>Because the index volatility is fixed by construction, Natixis can hedge with delta only and price the option off a known vol. That is what makes 163% participation possible on a 7Y Asian basket.</a:t>
             </a:r>
             <a:endParaRPr lang="en-US" dirty="0"/>
           </a:p>
@@ -3464,7 +3464,7 @@
           <a:p>
             <a:r>
               <a:rPr lang="en-US" dirty="0"/>
-              <a:t>Payoff = 100% + 164% x max(0, index perf). Scenario table from pricing/scenario2_vt_note.py, section 5. Historical rolling-window backtest to be added once the Bloomberg export is run (pricing/scenario2_backtest.py).</a:t>
+              <a:t>Payoff = 100% + 163% x max(0, index perf). Scenario table from pricing/scenario2_vt_note.py, section 5. Historical rolling-window backtest to be added once the Bloomberg export is run (pricing/scenario2_backtest.py).</a:t>
             </a:r>
             <a:endParaRPr lang="en-US" dirty="0"/>
           </a:p>
@@ -4010,7 +4010,7 @@
                 <a:ea typeface="Calibri" pitchFamily="34" charset="-122"/>
                 <a:cs typeface="Calibri" pitchFamily="34" charset="-120"/>
               </a:rPr>
-              <a:t>Every dollar back for the next generation, with 1.6x the upside of Asia's digital build-out</a:t>
+              <a:t>Every dollar back for the next generation, with 1.6x the upside of Asia's AI hardware build-out</a:t>
             </a:r>
             <a:endParaRPr lang="en-US" sz="1700" dirty="0"/>
           </a:p>
@@ -4120,7 +4120,7 @@
                 <a:ea typeface="Cambria" pitchFamily="34" charset="-122"/>
                 <a:cs typeface="Cambria" pitchFamily="34" charset="-120"/>
               </a:rPr>
-              <a:t>We turned down a 353% headline</a:t>
+              <a:t>We turned down a 351% headline</a:t>
             </a:r>
             <a:endParaRPr lang="en-US" sz="2600" dirty="0"/>
           </a:p>
@@ -4271,7 +4271,7 @@
                 <a:ea typeface="Calibri" pitchFamily="34" charset="-122"/>
                 <a:cs typeface="Calibri" pitchFamily="34" charset="-120"/>
               </a:rPr>
-              <a:t>highest median (1.59x) with a 12% chance of only 100 back, vs 35% for the 353% design. After 7 years of ~2.5% inflation, 100 back is a 16% real loss.</a:t>
+              <a:t>top-tier median (1.53x) with a 14% chance of only 100 back, vs 40% for the 351% design. After 7 years of ~2.5% inflation, 100 back is a 16% real loss.</a:t>
             </a:r>
             <a:endParaRPr lang="en-US" sz="1150" dirty="0"/>
           </a:p>
@@ -4716,7 +4716,7 @@
                           <a:ea typeface="Calibri" pitchFamily="34" charset="-122"/>
                           <a:cs typeface="Calibri" pitchFamily="34" charset="-120"/>
                         </a:rPr>
-                        <a:t>Asia tech crash: basket -30% in 1M</a:t>
+                        <a:t>AI hardware crash: basket -30% in 1M</a:t>
                       </a:r>
                       <a:endParaRPr lang="en-US" sz="1000" dirty="0">
                         <a:latin typeface="Calibri" charset="0"/>
@@ -4784,7 +4784,7 @@
                           <a:ea typeface="Calibri" pitchFamily="34" charset="-122"/>
                           <a:cs typeface="Calibri" pitchFamily="34" charset="-120"/>
                         </a:rPr>
-                        <a:t>-11.6%</a:t>
+                        <a:t>-9.4%</a:t>
                       </a:r>
                       <a:endParaRPr lang="en-US" sz="1000" dirty="0">
                         <a:latin typeface="Calibri" charset="0"/>
@@ -4852,7 +4852,7 @@
                           <a:ea typeface="Calibri" pitchFamily="34" charset="-122"/>
                           <a:cs typeface="Calibri" pitchFamily="34" charset="-120"/>
                         </a:rPr>
-                        <a:t>85.6</a:t>
+                        <a:t>87.5</a:t>
                       </a:r>
                       <a:endParaRPr lang="en-US" sz="1000" dirty="0">
                         <a:latin typeface="Calibri" charset="0"/>
@@ -4990,7 +4990,7 @@
                           <a:ea typeface="Calibri" pitchFamily="34" charset="-122"/>
                           <a:cs typeface="Calibri" pitchFamily="34" charset="-120"/>
                         </a:rPr>
-                        <a:t>-9.1%</a:t>
+                        <a:t>-7.4%</a:t>
                       </a:r>
                       <a:endParaRPr lang="en-US" sz="1000" dirty="0">
                         <a:latin typeface="Calibri" charset="0"/>
@@ -5058,7 +5058,7 @@
                           <a:ea typeface="Calibri" pitchFamily="34" charset="-122"/>
                           <a:cs typeface="Calibri" pitchFamily="34" charset="-120"/>
                         </a:rPr>
-                        <a:t>88.0</a:t>
+                        <a:t>89.7</a:t>
                       </a:r>
                       <a:endParaRPr lang="en-US" sz="1000" dirty="0">
                         <a:latin typeface="Calibri" charset="0"/>
@@ -5196,7 +5196,7 @@
                           <a:ea typeface="Calibri" pitchFamily="34" charset="-122"/>
                           <a:cs typeface="Calibri" pitchFamily="34" charset="-120"/>
                         </a:rPr>
-                        <a:t>-6.8%</a:t>
+                        <a:t>-5.6%</a:t>
                       </a:r>
                       <a:endParaRPr lang="en-US" sz="1000" dirty="0">
                         <a:latin typeface="Calibri" charset="0"/>
@@ -5264,7 +5264,7 @@
                           <a:ea typeface="Calibri" pitchFamily="34" charset="-122"/>
                           <a:cs typeface="Calibri" pitchFamily="34" charset="-120"/>
                         </a:rPr>
-                        <a:t>91.6</a:t>
+                        <a:t>93.1</a:t>
                       </a:r>
                       <a:endParaRPr lang="en-US" sz="1000" dirty="0">
                         <a:latin typeface="Calibri" charset="0"/>
@@ -5402,7 +5402,7 @@
                           <a:ea typeface="Calibri" pitchFamily="34" charset="-122"/>
                           <a:cs typeface="Calibri" pitchFamily="34" charset="-120"/>
                         </a:rPr>
-                        <a:t>+11.4%</a:t>
+                        <a:t>+9.3%</a:t>
                       </a:r>
                       <a:endParaRPr lang="en-US" sz="1000" dirty="0">
                         <a:latin typeface="Calibri" charset="0"/>
@@ -5470,7 +5470,7 @@
                           <a:ea typeface="Calibri" pitchFamily="34" charset="-122"/>
                           <a:cs typeface="Calibri" pitchFamily="34" charset="-120"/>
                         </a:rPr>
-                        <a:t>111.0</a:t>
+                        <a:t>108.3</a:t>
                       </a:r>
                       <a:endParaRPr lang="en-US" sz="1000" dirty="0">
                         <a:latin typeface="Calibri" charset="0"/>
@@ -5639,7 +5639,7 @@
                 <a:ea typeface="Calibri" pitchFamily="34" charset="-122"/>
                 <a:cs typeface="Calibri" pitchFamily="34" charset="-120"/>
               </a:rPr>
-              <a:t>USD 100Mn ÷ USD 2Bn = 5.0% of net worth. Contractual max loss at maturity: 0 (ex issuer default). Worst stress MTM: USD 12.4Mn ÷ USD 2Bn = 0.62% of net worth.</a:t>
+              <a:t>USD 100Mn ÷ USD 2Bn = 5.0% of net worth. Contractual max loss at maturity: 0 (ex issuer default). Worst stress MTM: USD 10.5Mn ÷ USD 2Bn = 0.52% of net worth.</a:t>
             </a:r>
             <a:endParaRPr lang="en-US" sz="1100" dirty="0"/>
           </a:p>
@@ -6265,7 +6265,7 @@
                 <a:ea typeface="Calibri" pitchFamily="34" charset="-122"/>
                 <a:cs typeface="Calibri" pitchFamily="34" charset="-120"/>
               </a:rPr>
-              <a:t>Also disclosed: Natixis credit risk · inflation erodes the real floor · VT lags V-shaped rebounds · quanto correlation · model risk on regime parameters.</a:t>
+              <a:t>Also disclosed: Natixis credit · Taiwan is 6 of 13 names · semiconductor cycle · inflation erodes the real floor · VT lags V-shaped rebounds · quanto · model risk.</a:t>
             </a:r>
             <a:endParaRPr lang="en-US" sz="1000" dirty="0"/>
           </a:p>
@@ -6603,7 +6603,7 @@
                 <a:ea typeface="Calibri" pitchFamily="34" charset="-122"/>
                 <a:cs typeface="Calibri" pitchFamily="34" charset="-120"/>
               </a:rPr>
-              <a:t>167% uncapped participation in Asia's digital leaders</a:t>
+              <a:t>167% uncapped participation in Asia's AI-hardware leaders</a:t>
             </a:r>
             <a:endParaRPr lang="en-US" sz="1250" dirty="0"/>
           </a:p>
@@ -7526,7 +7526,7 @@
                           <a:ea typeface="Calibri" pitchFamily="34" charset="-122"/>
                           <a:cs typeface="Calibri" pitchFamily="34" charset="-120"/>
                         </a:rPr>
-                        <a:t>164%</a:t>
+                        <a:t>163%</a:t>
                       </a:r>
                       <a:endParaRPr lang="en-US" sz="1100" dirty="0">
                         <a:latin typeface="Calibri" charset="0"/>
@@ -9163,7 +9163,7 @@
                           <a:ea typeface="Calibri" pitchFamily="34" charset="-122"/>
                           <a:cs typeface="Calibri" pitchFamily="34" charset="-120"/>
                         </a:rPr>
-                        <a:t>22% calm / 45% stress</a:t>
+                        <a:t>27% calm / 50% stress</a:t>
                       </a:r>
                       <a:endParaRPr lang="en-US" sz="950" dirty="0">
                         <a:latin typeface="Calibri" charset="0"/>
@@ -9369,7 +9369,7 @@
                           <a:ea typeface="Calibri" pitchFamily="34" charset="-122"/>
                           <a:cs typeface="Calibri" pitchFamily="34" charset="-120"/>
                         </a:rPr>
-                        <a:t>30%</a:t>
+                        <a:t>33%</a:t>
                       </a:r>
                       <a:endParaRPr lang="en-US" sz="950" dirty="0">
                         <a:latin typeface="Calibri" charset="0"/>
@@ -10481,7 +10481,7 @@
                 <a:ea typeface="Calibri" pitchFamily="34" charset="-122"/>
                 <a:cs typeface="Calibri" pitchFamily="34" charset="-120"/>
               </a:rPr>
-              <a:t>Uncapped, on a 10% vol-target index of 13 Asian digital leaders, with Legacy Lock</a:t>
+              <a:t>Uncapped, on a 10% vol-target index of 13 Asian AI-hardware leaders, with Legacy Lock</a:t>
             </a:r>
             <a:endParaRPr lang="en-US" sz="1150" dirty="0"/>
           </a:p>
@@ -10547,7 +10547,7 @@
                 <a:ea typeface="Cambria" pitchFamily="34" charset="-122"/>
                 <a:cs typeface="Cambria" pitchFamily="34" charset="-120"/>
               </a:rPr>
-              <a:t>0.62%</a:t>
+              <a:t>0.52%</a:t>
             </a:r>
             <a:endParaRPr lang="en-US" sz="4000" dirty="0"/>
           </a:p>
@@ -10625,7 +10625,7 @@
                 <a:ea typeface="Calibri" pitchFamily="34" charset="-122"/>
                 <a:cs typeface="Calibri" pitchFamily="34" charset="-120"/>
               </a:rPr>
-              <a:t>Worst stress mark-to-market (USD 12.4Mn) before maturity</a:t>
+              <a:t>Worst stress mark-to-market (USD 10.5Mn) before maturity</a:t>
             </a:r>
             <a:endParaRPr lang="en-US" sz="1150" dirty="0"/>
           </a:p>
@@ -10692,7 +10692,7 @@
                 <a:ea typeface="Calibri" pitchFamily="34" charset="-122"/>
                 <a:cs typeface="Calibri" pitchFamily="34" charset="-120"/>
               </a:rPr>
-              <a:t> on the Asia Digital Bridge 10% Vol-Target Index, to express our view that Asia owns the hardware and platforms of the AI era, while volatility and geopolitics argue for protected exposure. </a:t>
+              <a:t> on the Asia Digital Bridge 10% Vol-Target Index, to express our view that Asia builds the hardware of the AI era, while volatility and geopolitics argue for protected exposure. </a:t>
             </a:r>
             <a:pPr indent="0" marL="0">
               <a:buNone/>
@@ -10706,7 +10706,7 @@
                 <a:ea typeface="Calibri" pitchFamily="34" charset="-122"/>
                 <a:cs typeface="Calibri" pitchFamily="34" charset="-120"/>
               </a:rPr>
-              <a:t>Median outcome 1.41x–1.59x of capital in our 6–9% basket-return cases (vs 1.38x for a 7Y Treasury). Maximum loss at maturity: zero, contractual, ex issuer default.</a:t>
+              <a:t>Median outcome 1.38x–1.53x of capital in our 6–9% basket-return cases (vs 1.38x for a 7Y Treasury). Maximum loss at maturity: zero, contractual, ex issuer default.</a:t>
             </a:r>
             <a:endParaRPr lang="en-US" sz="1250" dirty="0"/>
           </a:p>
@@ -11565,7 +11565,7 @@
                 <a:ea typeface="Calibri" pitchFamily="34" charset="-122"/>
                 <a:cs typeface="Calibri" pitchFamily="34" charset="-120"/>
               </a:rPr>
-              <a:t>the family already earns its wealth in Asian infrastructure, renewables and property. We give digital exposure through chips, AI and platforms, exclude those sectors, and pay in USD so the note adds no JPY/HKD/CNY risk.</a:t>
+              <a:t>the family already earns its wealth in Asian infrastructure, renewables and property. We own the AI hardware layer (chips, memory, equipment, servers), exclude data centres, telecom towers, renewables and property, and pay in USD so the note adds no JPY/HKD/CNY risk.</a:t>
             </a:r>
             <a:endParaRPr lang="en-US" sz="1200" dirty="0"/>
           </a:p>
@@ -11675,7 +11675,7 @@
                 <a:ea typeface="Cambria" pitchFamily="34" charset="-122"/>
                 <a:cs typeface="Cambria" pitchFamily="34" charset="-120"/>
               </a:rPr>
-              <a:t>Asia owns the hardware and platforms of the AI era</a:t>
+              <a:t>Asia builds the hardware of the AI era</a:t>
             </a:r>
             <a:endParaRPr lang="en-US" sz="2600" dirty="0"/>
           </a:p>
@@ -11780,7 +11780,7 @@
                 <a:ea typeface="Cambria" pitchFamily="34" charset="-122"/>
                 <a:cs typeface="Cambria" pitchFamily="34" charset="-120"/>
               </a:rPr>
-              <a:t>Design</a:t>
+              <a:t>Chips</a:t>
             </a:r>
             <a:endParaRPr lang="en-US" sz="1350" dirty="0"/>
           </a:p>
@@ -11819,7 +11819,7 @@
                 <a:ea typeface="Calibri" pitchFamily="34" charset="-122"/>
                 <a:cs typeface="Calibri" pitchFamily="34" charset="-120"/>
               </a:rPr>
-              <a:t>MediaTek</a:t>
+              <a:t>TSMC · MediaTek</a:t>
             </a:r>
             <a:endParaRPr lang="en-US" sz="1050" dirty="0"/>
           </a:p>
@@ -11924,7 +11924,7 @@
                 <a:ea typeface="Cambria" pitchFamily="34" charset="-122"/>
                 <a:cs typeface="Cambria" pitchFamily="34" charset="-120"/>
               </a:rPr>
-              <a:t>Foundry</a:t>
+              <a:t>Memory</a:t>
             </a:r>
             <a:endParaRPr lang="en-US" sz="1350" dirty="0"/>
           </a:p>
@@ -11963,7 +11963,7 @@
                 <a:ea typeface="Calibri" pitchFamily="34" charset="-122"/>
                 <a:cs typeface="Calibri" pitchFamily="34" charset="-120"/>
               </a:rPr>
-              <a:t>TSMC</a:t>
+              <a:t>SK Hynix · Samsung</a:t>
             </a:r>
             <a:endParaRPr lang="en-US" sz="1050" dirty="0"/>
           </a:p>
@@ -12068,7 +12068,7 @@
                 <a:ea typeface="Cambria" pitchFamily="34" charset="-122"/>
                 <a:cs typeface="Cambria" pitchFamily="34" charset="-120"/>
               </a:rPr>
-              <a:t>Memory</a:t>
+              <a:t>Equipment</a:t>
             </a:r>
             <a:endParaRPr lang="en-US" sz="1350" dirty="0"/>
           </a:p>
@@ -12107,7 +12107,7 @@
                 <a:ea typeface="Calibri" pitchFamily="34" charset="-122"/>
                 <a:cs typeface="Calibri" pitchFamily="34" charset="-120"/>
               </a:rPr>
-              <a:t>SK Hynix · Samsung</a:t>
+              <a:t>Tokyo Electron · Advantest · Disco · Shin-Etsu</a:t>
             </a:r>
             <a:endParaRPr lang="en-US" sz="1050" dirty="0"/>
           </a:p>
@@ -12212,7 +12212,7 @@
                 <a:ea typeface="Cambria" pitchFamily="34" charset="-122"/>
                 <a:cs typeface="Cambria" pitchFamily="34" charset="-120"/>
               </a:rPr>
-              <a:t>Equipment</a:t>
+              <a:t>Packaging</a:t>
             </a:r>
             <a:endParaRPr lang="en-US" sz="1350" dirty="0"/>
           </a:p>
@@ -12251,7 +12251,7 @@
                 <a:ea typeface="Calibri" pitchFamily="34" charset="-122"/>
                 <a:cs typeface="Calibri" pitchFamily="34" charset="-120"/>
               </a:rPr>
-              <a:t>Tokyo Electron · Advantest</a:t>
+              <a:t>ASE · Ibiden</a:t>
             </a:r>
             <a:endParaRPr lang="en-US" sz="1050" dirty="0"/>
           </a:p>
@@ -12356,7 +12356,7 @@
                 <a:ea typeface="Cambria" pitchFamily="34" charset="-122"/>
                 <a:cs typeface="Cambria" pitchFamily="34" charset="-120"/>
               </a:rPr>
-              <a:t>Platforms</a:t>
+              <a:t>Servers</a:t>
             </a:r>
             <a:endParaRPr lang="en-US" sz="1350" dirty="0"/>
           </a:p>
@@ -12395,7 +12395,7 @@
                 <a:ea typeface="Calibri" pitchFamily="34" charset="-122"/>
                 <a:cs typeface="Calibri" pitchFamily="34" charset="-120"/>
               </a:rPr>
-              <a:t>Tencent · Alibaba · Xiaomi</a:t>
+              <a:t>Hon Hai · Quanta · Delta</a:t>
             </a:r>
             <a:endParaRPr lang="en-US" sz="1050" dirty="0"/>
           </a:p>
@@ -12434,7 +12434,7 @@
                 <a:ea typeface="Calibri" pitchFamily="34" charset="-122"/>
                 <a:cs typeface="Calibri" pitchFamily="34" charset="-120"/>
               </a:rPr>
-              <a:t>The AI value chain runs through Taiwan, Korea, Japan and China. Our basket owns every link.</a:t>
+              <a:t>Every AI accelerator passes through Taiwan, Korea and Japan. Our basket owns every step from wafer to server rack.</a:t>
             </a:r>
             <a:endParaRPr lang="en-US" sz="1150" dirty="0"/>
           </a:p>
@@ -12571,7 +12571,7 @@
                 <a:ea typeface="Calibri" pitchFamily="34" charset="-122"/>
                 <a:cs typeface="Calibri" pitchFamily="34" charset="-120"/>
               </a:rPr>
-              <a:t>Data-centre and AI spending drives demand for leading-edge chips, HBM memory and test equipment: segments Asian firms dominate.</a:t>
+              <a:t>Hyperscaler AI spending flows to leading-edge chips, HBM memory, test equipment and AI servers: segments Asian firms dominate.</a:t>
             </a:r>
             <a:endParaRPr lang="en-US" sz="1150" dirty="0"/>
           </a:p>
@@ -12669,7 +12669,7 @@
                 <a:ea typeface="Cambria" pitchFamily="34" charset="-122"/>
                 <a:cs typeface="Cambria" pitchFamily="34" charset="-120"/>
               </a:rPr>
-              <a:t>Champions go digital</a:t>
+              <a:t>Old makers, new role</a:t>
             </a:r>
             <a:endParaRPr lang="en-US" sz="1400" dirty="0"/>
           </a:p>
@@ -12708,7 +12708,7 @@
                 <a:ea typeface="Calibri" pitchFamily="34" charset="-122"/>
                 <a:cs typeface="Calibri" pitchFamily="34" charset="-120"/>
               </a:rPr>
-              <a:t>Japan's governance reforms and Korea's Value-up programme reward incumbents moving into digital: Sony, Hitachi, SoftBank, Keyence.</a:t>
+              <a:t>Traditional manufacturers (Hon Hai, Shin-Etsu, Ibiden) are now critical AI suppliers: the bridge the family asked for. HBM and packaging are capacity-constrained.</a:t>
             </a:r>
             <a:endParaRPr lang="en-US" sz="1150" dirty="0"/>
           </a:p>
@@ -13387,7 +13387,7 @@
                           <a:ea typeface="Calibri" pitchFamily="34" charset="-122"/>
                           <a:cs typeface="Calibri" pitchFamily="34" charset="-120"/>
                         </a:rPr>
-                        <a:t>28–51% chance of losing money over 7Y in our simulation; no floor for heirs</a:t>
+                        <a:t>35%–56% chance of losing money over 7Y in our simulation; no floor for heirs</a:t>
                       </a:r>
                       <a:endParaRPr lang="en-US" sz="1050" dirty="0">
                         <a:latin typeface="Calibri" charset="0"/>
@@ -14005,7 +14005,7 @@
                           <a:ea typeface="Calibri" pitchFamily="34" charset="-122"/>
                           <a:cs typeface="Calibri" pitchFamily="34" charset="-120"/>
                         </a:rPr>
-                        <a:t>No liquid 7Y Asian single-stock vol: dealer charges ~30% IV, so only 95% participation</a:t>
+                        <a:t>No liquid 7Y Asian single-stock vol: dealer charges ~33% IV, so only 89% participation</a:t>
                       </a:r>
                       <a:endParaRPr lang="en-US" sz="1050" dirty="0">
                         <a:latin typeface="Calibri" charset="0"/>
@@ -14143,7 +14143,7 @@
                           <a:ea typeface="Calibri" pitchFamily="34" charset="-122"/>
                           <a:cs typeface="Calibri" pitchFamily="34" charset="-120"/>
                         </a:rPr>
-                        <a:t>Protected, 164% participation</a:t>
+                        <a:t>Protected, 163% participation</a:t>
                       </a:r>
                       <a:endParaRPr lang="en-US" sz="1050" dirty="0">
                         <a:latin typeface="Calibri" charset="0"/>
@@ -14695,7 +14695,7 @@
                 <a:ea typeface="Calibri" pitchFamily="34" charset="-122"/>
                 <a:cs typeface="Calibri" pitchFamily="34" charset="-120"/>
               </a:rPr>
-              <a:t>Semiconductors (6)</a:t>
+              <a:t>AI chips and HBM memory (4)</a:t>
             </a:r>
             <a:endParaRPr lang="en-US" sz="1200" dirty="0"/>
           </a:p>
@@ -14734,7 +14734,7 @@
                 <a:ea typeface="Calibri" pitchFamily="34" charset="-122"/>
                 <a:cs typeface="Calibri" pitchFamily="34" charset="-120"/>
               </a:rPr>
-              <a:t>TSMC · Samsung · SK Hynix · MediaTek · Tokyo Electron · Advantest</a:t>
+              <a:t>TSMC · MediaTek · SK Hynix · Samsung Electronics</a:t>
             </a:r>
             <a:endParaRPr lang="en-US" sz="1100" dirty="0"/>
           </a:p>
@@ -14793,7 +14793,7 @@
                 <a:ea typeface="Calibri" pitchFamily="34" charset="-122"/>
                 <a:cs typeface="Calibri" pitchFamily="34" charset="-120"/>
               </a:rPr>
-              <a:t>Traditional champions going digital (4)</a:t>
+              <a:t>Equipment, materials and packaging (6)</a:t>
             </a:r>
             <a:endParaRPr lang="en-US" sz="1200" dirty="0"/>
           </a:p>
@@ -14832,7 +14832,7 @@
                 <a:ea typeface="Calibri" pitchFamily="34" charset="-122"/>
                 <a:cs typeface="Calibri" pitchFamily="34" charset="-120"/>
               </a:rPr>
-              <a:t>Sony · Hitachi · SoftBank Group · Keyence</a:t>
+              <a:t>Tokyo Electron · Advantest · Disco · Shin-Etsu · ASE · Ibiden</a:t>
             </a:r>
             <a:endParaRPr lang="en-US" sz="1100" dirty="0"/>
           </a:p>
@@ -14891,7 +14891,7 @@
                 <a:ea typeface="Calibri" pitchFamily="34" charset="-122"/>
                 <a:cs typeface="Calibri" pitchFamily="34" charset="-120"/>
               </a:rPr>
-              <a:t>Platforms (3)</a:t>
+              <a:t>AI servers and data-centre power (3)</a:t>
             </a:r>
             <a:endParaRPr lang="en-US" sz="1200" dirty="0"/>
           </a:p>
@@ -14930,7 +14930,7 @@
                 <a:ea typeface="Calibri" pitchFamily="34" charset="-122"/>
                 <a:cs typeface="Calibri" pitchFamily="34" charset="-120"/>
               </a:rPr>
-              <a:t>Tencent · Alibaba · Xiaomi</a:t>
+              <a:t>Hon Hai (Foxconn) · Quanta Computer · Delta Electronics</a:t>
             </a:r>
             <a:endParaRPr lang="en-US" sz="1100" dirty="0"/>
           </a:p>
@@ -14996,7 +14996,7 @@
                 <a:ea typeface="Calibri" pitchFamily="34" charset="-122"/>
                 <a:cs typeface="Calibri" pitchFamily="34" charset="-120"/>
               </a:rPr>
-              <a:t>Excluded on purpose: renewables, real estate, data-centre REITs (family overlap) and US-restricted names (e.g. SMIC). All names &gt; USD 250M market cap, &gt; USD 5M daily volume, on Bloomberg.</a:t>
+              <a:t>Excluded on purpose: data-centre operators and REITs, telecom towers, renewables (family overlap) and US-restricted chipmakers (e.g. SMIC). All names &gt; USD 250M market cap, &gt; USD 5M daily volume, on Bloomberg.</a:t>
             </a:r>
             <a:endParaRPr lang="en-US" sz="1050" dirty="0"/>
           </a:p>
@@ -15677,7 +15677,7 @@
                 <a:ea typeface="Calibri" pitchFamily="34" charset="-122"/>
                 <a:cs typeface="Calibri" pitchFamily="34" charset="-120"/>
               </a:rPr>
-              <a:t>Calm market (22% vol): </a:t>
+              <a:t>Calm market (27% vol): </a:t>
             </a:r>
             <a:pPr indent="0" marL="0">
               <a:buNone/>
@@ -15691,7 +15691,7 @@
                 <a:ea typeface="Calibri" pitchFamily="34" charset="-122"/>
                 <a:cs typeface="Calibri" pitchFamily="34" charset="-120"/>
               </a:rPr>
-              <a:t>~45% exposure. </a:t>
+              <a:t>~37% exposure. </a:t>
             </a:r>
             <a:pPr indent="0" marL="0">
               <a:buNone/>
@@ -15705,7 +15705,7 @@
                 <a:ea typeface="Calibri" pitchFamily="34" charset="-122"/>
                 <a:cs typeface="Calibri" pitchFamily="34" charset="-120"/>
               </a:rPr>
-              <a:t>Crash (45% vol): </a:t>
+              <a:t>Crash (50% vol): </a:t>
             </a:r>
             <a:pPr indent="0" marL="0">
               <a:buNone/>
@@ -15719,7 +15719,7 @@
                 <a:ea typeface="Calibri" pitchFamily="34" charset="-122"/>
                 <a:cs typeface="Calibri" pitchFamily="34" charset="-120"/>
               </a:rPr>
-              <a:t>~22% exposure, cut automatically.</a:t>
+              <a:t>~20% exposure, cut automatically.</a:t>
             </a:r>
             <a:endParaRPr lang="en-US" sz="1150" dirty="0"/>
           </a:p>
@@ -15758,7 +15758,7 @@
                 <a:ea typeface="Calibri" pitchFamily="34" charset="-122"/>
                 <a:cs typeface="Calibri" pitchFamily="34" charset="-120"/>
               </a:rPr>
-              <a:t>Simulated: average exposure 41%, realised index volatility 9.8% vs 10% target (lag creates small gap risk, priced in the Monte Carlo).</a:t>
+              <a:t>Simulated: average exposure 34%, realised index volatility 9.8% vs 10% target (lag creates small gap risk, priced in the Monte Carlo).</a:t>
             </a:r>
             <a:endParaRPr lang="en-US" sz="800" dirty="0"/>
           </a:p>
@@ -16853,7 +16853,7 @@
                           <a:ea typeface="Calibri" pitchFamily="34" charset="-122"/>
                           <a:cs typeface="Calibri" pitchFamily="34" charset="-120"/>
                         </a:rPr>
-                        <a:t>164% base · 167% with Lock + averaging</a:t>
+                        <a:t>163% base · 167% with Lock + averaging</a:t>
                       </a:r>
                       <a:endParaRPr lang="en-US" sz="1000" dirty="0">
                         <a:latin typeface="Calibri" charset="0"/>
@@ -17881,7 +17881,7 @@
                 <a:ea typeface="Calibri" pitchFamily="34" charset="-122"/>
                 <a:cs typeface="Calibri" pitchFamily="34" charset="-120"/>
               </a:rPr>
-              <a:t>18.5%</a:t>
+              <a:t>18.6%</a:t>
             </a:r>
             <a:endParaRPr lang="en-US" sz="1200" dirty="0"/>
           </a:p>
@@ -17986,7 +17986,7 @@
                 <a:ea typeface="Calibri" pitchFamily="34" charset="-122"/>
                 <a:cs typeface="Calibri" pitchFamily="34" charset="-120"/>
               </a:rPr>
-              <a:t>164%</a:t>
+              <a:t>163%</a:t>
             </a:r>
             <a:endParaRPr lang="en-US" sz="1200" dirty="0"/>
           </a:p>
@@ -18691,7 +18691,7 @@
                           <a:ea typeface="Calibri" pitchFamily="34" charset="-122"/>
                           <a:cs typeface="Calibri" pitchFamily="34" charset="-120"/>
                         </a:rPr>
-                        <a:t>0.98x</a:t>
+                        <a:t>0.89x</a:t>
                       </a:r>
                       <a:endParaRPr lang="en-US" sz="1000" dirty="0">
                         <a:latin typeface="Calibri" charset="0"/>
@@ -18759,7 +18759,7 @@
                           <a:ea typeface="Calibri" pitchFamily="34" charset="-122"/>
                           <a:cs typeface="Calibri" pitchFamily="34" charset="-120"/>
                         </a:rPr>
-                        <a:t>0.32x</a:t>
+                        <a:t>0.24x</a:t>
                       </a:r>
                       <a:endParaRPr lang="en-US" sz="1000" dirty="0">
                         <a:latin typeface="Calibri" charset="0"/>
@@ -18897,7 +18897,7 @@
                           <a:ea typeface="Calibri" pitchFamily="34" charset="-122"/>
                           <a:cs typeface="Calibri" pitchFamily="34" charset="-120"/>
                         </a:rPr>
-                        <a:t>1.41x</a:t>
+                        <a:t>1.38x</a:t>
                       </a:r>
                       <a:endParaRPr lang="en-US" sz="1000" dirty="0">
                         <a:latin typeface="Calibri" charset="0"/>
@@ -18965,7 +18965,7 @@
                           <a:ea typeface="Calibri" pitchFamily="34" charset="-122"/>
                           <a:cs typeface="Calibri" pitchFamily="34" charset="-120"/>
                         </a:rPr>
-                        <a:t>1.21x</a:t>
+                        <a:t>1.10x</a:t>
                       </a:r>
                       <a:endParaRPr lang="en-US" sz="1000" dirty="0">
                         <a:latin typeface="Calibri" charset="0"/>
@@ -19033,7 +19033,7 @@
                           <a:ea typeface="Calibri" pitchFamily="34" charset="-122"/>
                           <a:cs typeface="Calibri" pitchFamily="34" charset="-120"/>
                         </a:rPr>
-                        <a:t>0.40x</a:t>
+                        <a:t>0.29x</a:t>
                       </a:r>
                       <a:endParaRPr lang="en-US" sz="1000" dirty="0">
                         <a:latin typeface="Calibri" charset="0"/>
@@ -19171,7 +19171,7 @@
                           <a:ea typeface="Calibri" pitchFamily="34" charset="-122"/>
                           <a:cs typeface="Calibri" pitchFamily="34" charset="-120"/>
                         </a:rPr>
-                        <a:t>1.59x</a:t>
+                        <a:t>1.53x</a:t>
                       </a:r>
                       <a:endParaRPr lang="en-US" sz="1000" dirty="0">
                         <a:latin typeface="Calibri" charset="0"/>
@@ -19239,7 +19239,7 @@
                           <a:ea typeface="Calibri" pitchFamily="34" charset="-122"/>
                           <a:cs typeface="Calibri" pitchFamily="34" charset="-120"/>
                         </a:rPr>
-                        <a:t>1.49x</a:t>
+                        <a:t>1.36x</a:t>
                       </a:r>
                       <a:endParaRPr lang="en-US" sz="1000" dirty="0">
                         <a:latin typeface="Calibri" charset="0"/>
@@ -19307,7 +19307,7 @@
                           <a:ea typeface="Calibri" pitchFamily="34" charset="-122"/>
                           <a:cs typeface="Calibri" pitchFamily="34" charset="-120"/>
                         </a:rPr>
-                        <a:t>0.49x</a:t>
+                        <a:t>0.36x</a:t>
                       </a:r>
                       <a:endParaRPr lang="en-US" sz="1000" dirty="0">
                         <a:latin typeface="Calibri" charset="0"/>
@@ -19465,7 +19465,7 @@
                 <a:ea typeface="Calibri" pitchFamily="34" charset="-122"/>
                 <a:cs typeface="Calibri" pitchFamily="34" charset="-120"/>
               </a:rPr>
-              <a:t>0.32x–0.49x. The note beats direct ownership at the median in every regime and never loses capital.</a:t>
+              <a:t>0.24x–0.36x. The note beats direct ownership at the median in every regime and never loses capital.</a:t>
             </a:r>
             <a:endParaRPr lang="en-US" sz="1150" dirty="0"/>
           </a:p>
@@ -19504,7 +19504,7 @@
                 <a:ea typeface="Calibri" pitchFamily="34" charset="-122"/>
                 <a:cs typeface="Calibri" pitchFamily="34" charset="-120"/>
               </a:rPr>
-              <a:t>Forward simulation (20k paths, two-regime basket volatility 22%/45%), not a historical backtest. Indicative pricing: Monte Carlo with placeholder market inputs.</a:t>
+              <a:t>Forward simulation (20k paths, two-regime basket volatility 27%/50%), not a historical backtest. Indicative pricing: Monte Carlo with placeholder market inputs.</a:t>
             </a:r>
             <a:endParaRPr lang="en-US" sz="800" dirty="0"/>
           </a:p>

</xml_diff>